<commit_message>
updates to slides for week 3
</commit_message>
<xml_diff>
--- a/slides/Week3_Jobs_CICD.pptx
+++ b/slides/Week3_Jobs_CICD.pptx
@@ -3861,7 +3861,7 @@
                 <a:ea typeface="Arial"/>
                 <a:cs typeface="Arial"/>
               </a:rPr>
-              <a:t>TWO LAYERS, FOUR OBJECTIVES   </a:t>
+              <a:t xml:space="preserve">TWO LAYERS, FOUR OBJECTIVES   </a:t>
             </a:r>
             <a:r>
               <a:rPr sz="1100">
@@ -5111,7 +5111,7 @@
                 <a:ea typeface="Arial"/>
                 <a:cs typeface="Arial"/>
               </a:rPr>
-              <a:t>EXAM QUESTION SHAPE   </a:t>
+              <a:t xml:space="preserve">EXAM QUESTION SHAPE   </a:t>
             </a:r>
             <a:r>
               <a:rPr sz="1100">
@@ -5524,7 +5524,7 @@
                 <a:ea typeface="Consolas"/>
                 <a:cs typeface="Consolas"/>
               </a:rPr>
-              <a:t>  name: brewmart_pipeline</a:t>
+              <a:t xml:space="preserve">  name: brewmart_pipeline</a:t>
             </a:r>
           </a:p>
           <a:p xmlns:a="http://schemas.openxmlformats.org/drawingml/2006/main">
@@ -5562,7 +5562,7 @@
                 <a:ea typeface="Consolas"/>
                 <a:cs typeface="Consolas"/>
               </a:rPr>
-              <a:t>  target_schema:</a:t>
+              <a:t xml:space="preserve">  target_schema:</a:t>
             </a:r>
           </a:p>
           <a:p xmlns:a="http://schemas.openxmlformats.org/drawingml/2006/main">
@@ -5581,7 +5581,7 @@
                 <a:ea typeface="Consolas"/>
                 <a:cs typeface="Consolas"/>
               </a:rPr>
-              <a:t>    default: lab1_dev</a:t>
+              <a:t xml:space="preserve">    default: lab1_dev</a:t>
             </a:r>
           </a:p>
           <a:p xmlns:a="http://schemas.openxmlformats.org/drawingml/2006/main">
@@ -5619,7 +5619,7 @@
                 <a:ea typeface="Consolas"/>
                 <a:cs typeface="Consolas"/>
               </a:rPr>
-              <a:t>  jobs:</a:t>
+              <a:t xml:space="preserve">  jobs:</a:t>
             </a:r>
           </a:p>
           <a:p xmlns:a="http://schemas.openxmlformats.org/drawingml/2006/main">
@@ -5638,7 +5638,7 @@
                 <a:ea typeface="Consolas"/>
                 <a:cs typeface="Consolas"/>
               </a:rPr>
-              <a:t>    brewmart_daily:</a:t>
+              <a:t xml:space="preserve">    brewmart_daily:</a:t>
             </a:r>
           </a:p>
           <a:p xmlns:a="http://schemas.openxmlformats.org/drawingml/2006/main">
@@ -5657,7 +5657,7 @@
                 <a:ea typeface="Consolas"/>
                 <a:cs typeface="Consolas"/>
               </a:rPr>
-              <a:t>      tasks: [...]         #   depends_on lives here</a:t>
+              <a:t xml:space="preserve">      tasks: [...]         #   depends_on lives here</a:t>
             </a:r>
           </a:p>
           <a:p xmlns:a="http://schemas.openxmlformats.org/drawingml/2006/main">
@@ -5695,7 +5695,7 @@
                 <a:ea typeface="Consolas"/>
                 <a:cs typeface="Consolas"/>
               </a:rPr>
-              <a:t>  dev:  { variables: { target_schema: lab1_dev } }</a:t>
+              <a:t xml:space="preserve">  dev:  { variables: { target_schema: lab1_dev } }</a:t>
             </a:r>
           </a:p>
           <a:p xmlns:a="http://schemas.openxmlformats.org/drawingml/2006/main">
@@ -5714,7 +5714,7 @@
                 <a:ea typeface="Consolas"/>
                 <a:cs typeface="Consolas"/>
               </a:rPr>
-              <a:t>  prod: { mode: production,</a:t>
+              <a:t xml:space="preserve">  prod: { mode: production,</a:t>
             </a:r>
           </a:p>
           <a:p xmlns:a="http://schemas.openxmlformats.org/drawingml/2006/main">
@@ -5733,7 +5733,7 @@
                 <a:ea typeface="Consolas"/>
                 <a:cs typeface="Consolas"/>
               </a:rPr>
-              <a:t>          variables: { target_schema: sales_prod } }</a:t>
+              <a:t xml:space="preserve">          variables: { target_schema: sales_prod } }</a:t>
             </a:r>
           </a:p>
         </p:txBody>
@@ -5808,7 +5808,7 @@
                 <a:ea typeface="Arial"/>
                 <a:cs typeface="Arial"/>
               </a:rPr>
-              <a:t>Same code, both targets  </a:t>
+              <a:t xml:space="preserve">Same code, both targets  </a:t>
             </a:r>
             <a:r>
               <a:rPr sz="1150">
@@ -5894,7 +5894,7 @@
                 <a:ea typeface="Arial"/>
                 <a:cs typeface="Arial"/>
               </a:rPr>
-              <a:t>Promotion  </a:t>
+              <a:t xml:space="preserve">Promotion  </a:t>
             </a:r>
             <a:r>
               <a:rPr sz="1150">
@@ -5980,7 +5980,7 @@
                 <a:ea typeface="Arial"/>
                 <a:cs typeface="Arial"/>
               </a:rPr>
-              <a:t>The UI job and this YAML  </a:t>
+              <a:t xml:space="preserve">The UI job and this YAML  </a:t>
             </a:r>
             <a:r>
               <a:rPr sz="1150">
@@ -6875,7 +6875,7 @@
                 <a:ea typeface="Arial"/>
                 <a:cs typeface="Arial"/>
               </a:rPr>
-              <a:t>THE CI SENTENCE (WORTH SEVERAL POINTS)   </a:t>
+              <a:t xml:space="preserve">THE CI SENTENCE (WORTH SEVERAL POINTS)   </a:t>
             </a:r>
             <a:r>
               <a:rPr sz="1100">
@@ -7947,7 +7947,7 @@
                 <a:ea typeface="Arial"/>
                 <a:cs typeface="Arial"/>
               </a:rPr>
-              <a:t>OLD-NAME BAIT   </a:t>
+              <a:t xml:space="preserve">OLD-NAME BAIT   </a:t>
             </a:r>
             <a:r>
               <a:rPr sz="1100">
@@ -8493,7 +8493,7 @@
                 <a:ea typeface="Consolas"/>
                 <a:cs typeface="Consolas"/>
               </a:rPr>
-              <a:t>  return spark.readStream.table('sales_bronze_dp')</a:t>
+              <a:t xml:space="preserve">  return spark.readStream.table('sales_bronze_dp')</a:t>
             </a:r>
           </a:p>
         </p:txBody>
@@ -8568,7 +8568,7 @@
                 <a:ea typeface="Arial"/>
                 <a:cs typeface="Arial"/>
               </a:rPr>
-              <a:t>Declarative  </a:t>
+              <a:t xml:space="preserve">Declarative  </a:t>
             </a:r>
             <a:r>
               <a:rPr sz="1150">
@@ -8730,7 +8730,7 @@
                 <a:ea typeface="Arial"/>
                 <a:cs typeface="Arial"/>
               </a:rPr>
-              <a:t>Table kinds  </a:t>
+              <a:t xml:space="preserve">Table kinds  </a:t>
             </a:r>
             <a:r>
               <a:rPr sz="1150">
@@ -9960,7 +9960,7 @@
                 <a:ea typeface="Arial"/>
                 <a:cs typeface="Arial"/>
               </a:rPr>
-              <a:t>YOU RUN   </a:t>
+              <a:t xml:space="preserve">YOU RUN   </a:t>
             </a:r>
             <a:r>
               <a:rPr sz="1100">
@@ -11238,7 +11238,7 @@
                 <a:ea typeface="Arial"/>
                 <a:cs typeface="Arial"/>
               </a:rPr>
-              <a:t>+</a:t>
+              <a:t>PLUS</a:t>
             </a:r>
           </a:p>
         </p:txBody>
@@ -11388,7 +11388,7 @@
                 <a:ea typeface="Arial"/>
                 <a:cs typeface="Arial"/>
               </a:rPr>
-              <a:t>ONE STORYLINE   </a:t>
+              <a:t xml:space="preserve">ONE STORYLINE   </a:t>
             </a:r>
             <a:r>
               <a:rPr sz="1100">
@@ -11683,7 +11683,7 @@
                 <a:ea typeface="Arial"/>
                 <a:cs typeface="Arial"/>
               </a:rPr>
-              <a:t>Job  </a:t>
+              <a:t xml:space="preserve">Job  </a:t>
             </a:r>
             <a:r>
               <a:rPr sz="1300">
@@ -11769,7 +11769,7 @@
                 <a:ea typeface="Arial"/>
                 <a:cs typeface="Arial"/>
               </a:rPr>
-              <a:t>Tasks  </a:t>
+              <a:t xml:space="preserve">Tasks  </a:t>
             </a:r>
             <a:r>
               <a:rPr sz="1300">
@@ -11855,7 +11855,7 @@
                 <a:ea typeface="Arial"/>
                 <a:cs typeface="Arial"/>
               </a:rPr>
-              <a:t>depends_on  </a:t>
+              <a:t xml:space="preserve">depends_on  </a:t>
             </a:r>
             <a:r>
               <a:rPr sz="1300">
@@ -13555,7 +13555,7 @@
                 <a:ea typeface="Arial"/>
                 <a:cs typeface="Arial"/>
               </a:rPr>
-              <a:t>ALSO RECOGNIZE ON SIGHT   </a:t>
+              <a:t xml:space="preserve">ALSO RECOGNIZE ON SIGHT   </a:t>
             </a:r>
             <a:r>
               <a:rPr sz="1100">
@@ -14709,7 +14709,7 @@
                 <a:ea typeface="Arial"/>
                 <a:cs typeface="Arial"/>
               </a:rPr>
-              <a:t>TRAP   </a:t>
+              <a:t xml:space="preserve">TRAP   </a:t>
             </a:r>
             <a:r>
               <a:rPr sz="1100">
@@ -16085,7 +16085,7 @@
                 <a:ea typeface="Arial"/>
                 <a:cs typeface="Arial"/>
               </a:rPr>
-              <a:t>EXAM ANSWER SHAPE   </a:t>
+              <a:t xml:space="preserve">EXAM ANSWER SHAPE   </a:t>
             </a:r>
             <a:r>
               <a:rPr sz="1100">
@@ -16536,7 +16536,7 @@
                 <a:ea typeface="Consolas"/>
                 <a:cs typeface="Consolas"/>
               </a:rPr>
-              <a:t> </a:t>
+              <a:t xml:space="preserve"> </a:t>
             </a:r>
           </a:p>
           <a:p xmlns:a="http://schemas.openxmlformats.org/drawingml/2006/main">
@@ -16631,7 +16631,7 @@
                 <a:ea typeface="Consolas"/>
                 <a:cs typeface="Consolas"/>
               </a:rPr>
-              <a:t>      taskKey='ingest', key='rows')</a:t>
+              <a:t xml:space="preserve">      taskKey='ingest', key='rows')</a:t>
             </a:r>
           </a:p>
         </p:txBody>
@@ -16706,7 +16706,7 @@
                 <a:ea typeface="Arial"/>
                 <a:cs typeface="Arial"/>
               </a:rPr>
-              <a:t>Job parameters  </a:t>
+              <a:t xml:space="preserve">Job parameters  </a:t>
             </a:r>
             <a:r>
               <a:rPr sz="1150">
@@ -16792,7 +16792,7 @@
                 <a:ea typeface="Arial"/>
                 <a:cs typeface="Arial"/>
               </a:rPr>
-              <a:t>Widgets  </a:t>
+              <a:t xml:space="preserve">Widgets  </a:t>
             </a:r>
             <a:r>
               <a:rPr sz="1150">
@@ -16878,7 +16878,7 @@
                 <a:ea typeface="Arial"/>
                 <a:cs typeface="Arial"/>
               </a:rPr>
-              <a:t>Task values  </a:t>
+              <a:t xml:space="preserve">Task values  </a:t>
             </a:r>
             <a:r>
               <a:rPr sz="1150">
@@ -16964,7 +16964,7 @@
                 <a:ea typeface="Arial"/>
                 <a:cs typeface="Arial"/>
               </a:rPr>
-              <a:t>References  </a:t>
+              <a:t xml:space="preserve">References  </a:t>
             </a:r>
             <a:r>
               <a:rPr sz="1150">
@@ -17259,7 +17259,7 @@
                 <a:ea typeface="Arial"/>
                 <a:cs typeface="Arial"/>
               </a:rPr>
-              <a:t>Run history  </a:t>
+              <a:t xml:space="preserve">Run history  </a:t>
             </a:r>
             <a:r>
               <a:rPr sz="1200">
@@ -17345,7 +17345,7 @@
                 <a:ea typeface="Arial"/>
                 <a:cs typeface="Arial"/>
               </a:rPr>
-              <a:t>Matrix view  </a:t>
+              <a:t xml:space="preserve">Matrix view  </a:t>
             </a:r>
             <a:r>
               <a:rPr sz="1200">
@@ -17431,7 +17431,7 @@
                 <a:ea typeface="Arial"/>
                 <a:cs typeface="Arial"/>
               </a:rPr>
-              <a:t>upstream-failed  </a:t>
+              <a:t xml:space="preserve">upstream-failed  </a:t>
             </a:r>
             <a:r>
               <a:rPr sz="1200">
@@ -17517,7 +17517,7 @@
                 <a:ea typeface="Arial"/>
                 <a:cs typeface="Arial"/>
               </a:rPr>
-              <a:t>Repair run  </a:t>
+              <a:t xml:space="preserve">Repair run  </a:t>
             </a:r>
             <a:r>
               <a:rPr sz="1200">
@@ -18865,7 +18865,7 @@
                 <a:ea typeface="Arial"/>
                 <a:cs typeface="Arial"/>
               </a:rPr>
-              <a:t>TRAP   </a:t>
+              <a:t xml:space="preserve">TRAP   </a:t>
             </a:r>
             <a:r>
               <a:rPr sz="1100">

</xml_diff>